<commit_message>
Image adjustment (minor TC)
</commit_message>
<xml_diff>
--- a/input/images-source/CRD_DTR_Flow.pptx
+++ b/input/images-source/CRD_DTR_Flow.pptx
@@ -3250,7 +3250,7 @@
           <a:p>
             <a:fld id="{FD8C879B-2DAC-426D-B5B4-08F42B952A26}" type="datetimeFigureOut">
               <a:rPr lang="en-US" smtClean="0"/>
-              <a:t>6/4/2026</a:t>
+              <a:t>6/5/2026</a:t>
             </a:fld>
             <a:endParaRPr lang="en-US" dirty="0"/>
           </a:p>
@@ -3427,7 +3427,7 @@
           <a:p>
             <a:fld id="{92E54576-A3BB-48F9-891E-992E86D01A7B}" type="datetimeFigureOut">
               <a:rPr lang="en-US" smtClean="0"/>
-              <a:t>6/4/2026</a:t>
+              <a:t>6/5/2026</a:t>
             </a:fld>
             <a:endParaRPr lang="en-US" dirty="0"/>
           </a:p>
@@ -7948,7 +7948,7 @@
           <a:p>
             <a:fld id="{41EA1E7C-71D6-4729-84AA-F013DDAF4032}" type="datetimeFigureOut">
               <a:rPr lang="en-US" smtClean="0"/>
-              <a:t>6/4/2026</a:t>
+              <a:t>6/5/2026</a:t>
             </a:fld>
             <a:endParaRPr lang="en-US" dirty="0"/>
           </a:p>
@@ -21693,10 +21693,10 @@
             <a:noFill/>
             <a:ln w="6350" cap="flat" cmpd="sng" algn="ctr">
               <a:solidFill>
-                <a:srgbClr val="000000">
+                <a:schemeClr val="tx1">
                   <a:lumMod val="50000"/>
                   <a:lumOff val="50000"/>
-                </a:srgbClr>
+                </a:schemeClr>
               </a:solidFill>
               <a:prstDash val="dash"/>
               <a:miter lim="800000"/>
@@ -23562,9 +23562,12 @@
             <a:noFill/>
             <a:ln w="6350" cap="flat" cmpd="sng" algn="ctr">
               <a:solidFill>
-                <a:srgbClr val="000000"/>
+                <a:schemeClr val="tx1">
+                  <a:lumMod val="50000"/>
+                  <a:lumOff val="50000"/>
+                </a:schemeClr>
               </a:solidFill>
-              <a:prstDash val="solid"/>
+              <a:prstDash val="dash"/>
               <a:miter lim="800000"/>
               <a:headEnd type="triangle"/>
               <a:tailEnd type="triangle"/>
@@ -23606,7 +23609,10 @@
               <a:r>
                 <a:rPr lang="en-US" sz="1050" kern="0" dirty="0">
                   <a:solidFill>
-                    <a:srgbClr val="000000"/>
+                    <a:schemeClr val="tx1">
+                      <a:lumMod val="65000"/>
+                      <a:lumOff val="35000"/>
+                    </a:schemeClr>
                   </a:solidFill>
                   <a:latin typeface="Calibri" panose="020F0502020204030204"/>
                   <a:ea typeface="ヒラギノ角ゴ Pro W3" pitchFamily="-126" charset="-128"/>
@@ -23826,8 +23832,8 @@
         </p:nvSpPr>
         <p:spPr>
           <a:xfrm>
-            <a:off x="8380188" y="4874975"/>
-            <a:ext cx="1302111" cy="307777"/>
+            <a:off x="8380188" y="4893081"/>
+            <a:ext cx="1302111" cy="256545"/>
           </a:xfrm>
           <a:prstGeom prst="rect">
             <a:avLst/>
@@ -23842,7 +23848,7 @@
           <a:p>
             <a:pPr algn="ctr" defTabSz="609585" fontAlgn="base">
               <a:lnSpc>
-                <a:spcPts val="1200"/>
+                <a:spcPts val="1000"/>
               </a:lnSpc>
               <a:spcBef>
                 <a:spcPct val="0"/>
@@ -23855,9 +23861,8 @@
             <a:r>
               <a:rPr lang="en-US" sz="950" i="1" kern="0" dirty="0">
                 <a:solidFill>
-                  <a:schemeClr val="tx1">
-                    <a:lumMod val="65000"/>
-                    <a:lumOff val="35000"/>
+                  <a:schemeClr val="accent1">
+                    <a:lumMod val="75000"/>
                   </a:schemeClr>
                 </a:solidFill>
                 <a:latin typeface="Calibri" panose="020F0502020204030204"/>
@@ -23868,9 +23873,8 @@
             </a:r>
             <a:endParaRPr lang="en-US" sz="950" i="1" kern="0" dirty="0">
               <a:solidFill>
-                <a:schemeClr val="tx1">
-                  <a:lumMod val="65000"/>
-                  <a:lumOff val="35000"/>
+                <a:schemeClr val="accent1">
+                  <a:lumMod val="75000"/>
                 </a:schemeClr>
               </a:solidFill>
               <a:ea typeface="ヒラギノ角ゴ Pro W3" pitchFamily="-126" charset="-128"/>
@@ -32015,27 +32019,12 @@
 </file>
 
 <file path=customXml/item1.xml><?xml version="1.0" encoding="utf-8"?>
-<p:properties xmlns:p="http://schemas.microsoft.com/office/2006/metadata/properties" xmlns:xsi="http://www.w3.org/2001/XMLSchema-instance" xmlns:pc="http://schemas.microsoft.com/office/infopath/2007/PartnerControls">
-  <documentManagement>
-    <SharedWithUsers xmlns="5bceed9a-bae5-4329-97ef-b259bd0b225e">
-      <UserInfo>
-        <DisplayName>Ambrose, Nalini</DisplayName>
-        <AccountId>13</AccountId>
-        <AccountType/>
-      </UserInfo>
-      <UserInfo>
-        <DisplayName>Lyall, Jessica</DisplayName>
-        <AccountId>178</AccountId>
-        <AccountType/>
-      </UserInfo>
-      <UserInfo>
-        <DisplayName>Horbachevsky, Olexa</DisplayName>
-        <AccountId>10</AccountId>
-        <AccountType/>
-      </UserInfo>
-    </SharedWithUsers>
-  </documentManagement>
-</p:properties>
+<?mso-contentType ?>
+<FormTemplates xmlns="http://schemas.microsoft.com/sharepoint/v3/contenttype/forms">
+  <Display>DocumentLibraryForm</Display>
+  <Edit>DocumentLibraryForm</Edit>
+  <New>DocumentLibraryForm</New>
+</FormTemplates>
 </file>
 
 <file path=customXml/item2.xml><?xml version="1.0" encoding="utf-8"?>
@@ -32236,27 +32225,33 @@
 </file>
 
 <file path=customXml/item3.xml><?xml version="1.0" encoding="utf-8"?>
-<?mso-contentType ?>
-<FormTemplates xmlns="http://schemas.microsoft.com/sharepoint/v3/contenttype/forms">
-  <Display>DocumentLibraryForm</Display>
-  <Edit>DocumentLibraryForm</Edit>
-  <New>DocumentLibraryForm</New>
-</FormTemplates>
+<p:properties xmlns:p="http://schemas.microsoft.com/office/2006/metadata/properties" xmlns:xsi="http://www.w3.org/2001/XMLSchema-instance" xmlns:pc="http://schemas.microsoft.com/office/infopath/2007/PartnerControls">
+  <documentManagement>
+    <SharedWithUsers xmlns="5bceed9a-bae5-4329-97ef-b259bd0b225e">
+      <UserInfo>
+        <DisplayName>Ambrose, Nalini</DisplayName>
+        <AccountId>13</AccountId>
+        <AccountType/>
+      </UserInfo>
+      <UserInfo>
+        <DisplayName>Lyall, Jessica</DisplayName>
+        <AccountId>178</AccountId>
+        <AccountType/>
+      </UserInfo>
+      <UserInfo>
+        <DisplayName>Horbachevsky, Olexa</DisplayName>
+        <AccountId>10</AccountId>
+        <AccountType/>
+      </UserInfo>
+    </SharedWithUsers>
+  </documentManagement>
+</p:properties>
 </file>
 
 <file path=customXml/itemProps1.xml><?xml version="1.0" encoding="utf-8"?>
-<ds:datastoreItem xmlns:ds="http://schemas.openxmlformats.org/officeDocument/2006/customXml" ds:itemID="{5450FCDD-08B1-48D8-BB50-7A17E590A5EE}">
+<ds:datastoreItem xmlns:ds="http://schemas.openxmlformats.org/officeDocument/2006/customXml" ds:itemID="{416BA5C9-2D71-4B86-AE8A-8C0D9BC5FB22}">
   <ds:schemaRefs>
-    <ds:schemaRef ds:uri="http://purl.org/dc/terms/"/>
-    <ds:schemaRef ds:uri="http://schemas.openxmlformats.org/package/2006/metadata/core-properties"/>
-    <ds:schemaRef ds:uri="http://purl.org/dc/dcmitype/"/>
-    <ds:schemaRef ds:uri="http://schemas.microsoft.com/office/infopath/2007/PartnerControls"/>
-    <ds:schemaRef ds:uri="http://schemas.microsoft.com/office/2006/documentManagement/types"/>
-    <ds:schemaRef ds:uri="5bceed9a-bae5-4329-97ef-b259bd0b225e"/>
-    <ds:schemaRef ds:uri="http://purl.org/dc/elements/1.1/"/>
-    <ds:schemaRef ds:uri="http://schemas.microsoft.com/office/2006/metadata/properties"/>
-    <ds:schemaRef ds:uri="c6e6fbc9-cbf1-42ee-bbf0-d6e110e2b732"/>
-    <ds:schemaRef ds:uri="http://www.w3.org/XML/1998/namespace"/>
+    <ds:schemaRef ds:uri="http://schemas.microsoft.com/sharepoint/v3/contenttype/forms"/>
   </ds:schemaRefs>
 </ds:datastoreItem>
 </file>
@@ -32281,9 +32276,18 @@
 </file>
 
 <file path=customXml/itemProps3.xml><?xml version="1.0" encoding="utf-8"?>
-<ds:datastoreItem xmlns:ds="http://schemas.openxmlformats.org/officeDocument/2006/customXml" ds:itemID="{416BA5C9-2D71-4B86-AE8A-8C0D9BC5FB22}">
+<ds:datastoreItem xmlns:ds="http://schemas.openxmlformats.org/officeDocument/2006/customXml" ds:itemID="{5450FCDD-08B1-48D8-BB50-7A17E590A5EE}">
   <ds:schemaRefs>
-    <ds:schemaRef ds:uri="http://schemas.microsoft.com/sharepoint/v3/contenttype/forms"/>
+    <ds:schemaRef ds:uri="http://purl.org/dc/terms/"/>
+    <ds:schemaRef ds:uri="http://schemas.openxmlformats.org/package/2006/metadata/core-properties"/>
+    <ds:schemaRef ds:uri="http://purl.org/dc/dcmitype/"/>
+    <ds:schemaRef ds:uri="http://schemas.microsoft.com/office/infopath/2007/PartnerControls"/>
+    <ds:schemaRef ds:uri="http://schemas.microsoft.com/office/2006/documentManagement/types"/>
+    <ds:schemaRef ds:uri="5bceed9a-bae5-4329-97ef-b259bd0b225e"/>
+    <ds:schemaRef ds:uri="http://purl.org/dc/elements/1.1/"/>
+    <ds:schemaRef ds:uri="http://schemas.microsoft.com/office/2006/metadata/properties"/>
+    <ds:schemaRef ds:uri="c6e6fbc9-cbf1-42ee-bbf0-d6e110e2b732"/>
+    <ds:schemaRef ds:uri="http://www.w3.org/XML/1998/namespace"/>
   </ds:schemaRefs>
 </ds:datastoreItem>
 </file>
</xml_diff>